<commit_message>
docs: refresh presentation decks and whitepapers with live demo and repository links
</commit_message>
<xml_diff>
--- a/docs/SnapShield_Pitch_Deck.pptx
+++ b/docs/SnapShield_Pitch_Deck.pptx
@@ -3209,9 +3209,9 @@
           <a:p>
             <a:pPr>
               <a:spcBef>
-                <a:spcPts val="2000"/>
-              </a:spcBef>
-              <a:defRPr sz="1300" b="1">
+                <a:spcPts val="1600"/>
+              </a:spcBef>
+              <a:defRPr sz="1200" b="1">
                 <a:solidFill>
                   <a:srgbClr val="3FB950"/>
                 </a:solidFill>
@@ -3219,7 +3219,11 @@
               </a:defRPr>
             </a:pPr>
             <a:r>
-              <a:t>Target Hardware: Snapdragon® X Elite &amp; HP OmniBook Ultra Copilot+ PCs (45 TOPS Hexagon NPU)</a:t>
+              <a:t>Target Platform: Snapdragon® X Elite &amp; HP OmniBook Ultra Copilot+ PCs (45 TOPS Hexagon NPU)</a:t>
+            </a:r>
+            <a:br/>
+            <a:r>
+              <a:t>Live Interactive Demo: https://snapshield-npu.streamlit.app  |  GitHub: https://github.com/Jeffreyryan2005/snapdragon</a:t>
             </a:r>
           </a:p>
         </p:txBody>
@@ -6147,23 +6151,39 @@
               </a:defRPr>
             </a:pPr>
             <a:r>
-              <a:t>• Two UI Interfaces: Broadcast OpenCV Cyber-HUD and interactive Streamlit web portal.</a:t>
-            </a:r>
-          </a:p>
-          <a:p>
-            <a:pPr>
-              <a:spcBef>
-                <a:spcPts val="800"/>
-              </a:spcBef>
-              <a:defRPr sz="1200">
-                <a:solidFill>
-                  <a:srgbClr val="F0F6FC"/>
-                </a:solidFill>
-                <a:latin typeface="Calibri"/>
-              </a:defRPr>
-            </a:pPr>
-            <a:r>
-              <a:t>• Automated test suite (100% pass rate) validating rPPG SNR, vocoder detection, and fusion decisions.</a:t>
+              <a:t>• GitHub: https://github.com/Jeffreyryan2005/snapdragon</a:t>
+            </a:r>
+          </a:p>
+          <a:p>
+            <a:pPr>
+              <a:spcBef>
+                <a:spcPts val="800"/>
+              </a:spcBef>
+              <a:defRPr sz="1200">
+                <a:solidFill>
+                  <a:srgbClr val="F0F6FC"/>
+                </a:solidFill>
+                <a:latin typeface="Calibri"/>
+              </a:defRPr>
+            </a:pPr>
+            <a:r>
+              <a:t>• Broadcast OpenCV Cyber-HUD (215+ FPS) and pre-recorded test video clips in data/samples/.</a:t>
+            </a:r>
+          </a:p>
+          <a:p>
+            <a:pPr>
+              <a:spcBef>
+                <a:spcPts val="800"/>
+              </a:spcBef>
+              <a:defRPr sz="1200">
+                <a:solidFill>
+                  <a:srgbClr val="F0F6FC"/>
+                </a:solidFill>
+                <a:latin typeface="Calibri"/>
+              </a:defRPr>
+            </a:pPr>
+            <a:r>
+              <a:t>• Automated test suite (100% pass rate) validating rPPG SNR and vocoder detection.</a:t>
             </a:r>
           </a:p>
         </p:txBody>
@@ -6218,55 +6238,71 @@
               </a:defRPr>
             </a:pPr>
             <a:r>
-              <a:t>2. Qualcomm AI Hub Suite</a:t>
-            </a:r>
-          </a:p>
-          <a:p>
-            <a:pPr>
-              <a:spcBef>
-                <a:spcPts val="800"/>
-              </a:spcBef>
-              <a:defRPr sz="1200">
-                <a:solidFill>
-                  <a:srgbClr val="F0F6FC"/>
-                </a:solidFill>
-                <a:latin typeface="Calibri"/>
-              </a:defRPr>
-            </a:pPr>
-            <a:r>
-              <a:t>• Dedicated 'compile_qai_hub.py' script targeting Snapdragon X Elite CRD.</a:t>
-            </a:r>
-          </a:p>
-          <a:p>
-            <a:pPr>
-              <a:spcBef>
-                <a:spcPts val="800"/>
-              </a:spcBef>
-              <a:defRPr sz="1200">
-                <a:solidFill>
-                  <a:srgbClr val="F0F6FC"/>
-                </a:solidFill>
-                <a:latin typeface="Calibri"/>
-              </a:defRPr>
-            </a:pPr>
-            <a:r>
-              <a:t>• Model graph tracing, quantization config, and cloud compilation automation.</a:t>
-            </a:r>
-          </a:p>
-          <a:p>
-            <a:pPr>
-              <a:spcBef>
-                <a:spcPts val="800"/>
-              </a:spcBef>
-              <a:defRPr sz="1200">
-                <a:solidFill>
-                  <a:srgbClr val="F0F6FC"/>
-                </a:solidFill>
-                <a:latin typeface="Calibri"/>
-              </a:defRPr>
-            </a:pPr>
-            <a:r>
-              <a:t>• Hardware performance benchmark logs integrated into repository.</a:t>
+              <a:t>2. Live Cloud Demo Portal</a:t>
+            </a:r>
+          </a:p>
+          <a:p>
+            <a:pPr>
+              <a:spcBef>
+                <a:spcPts val="800"/>
+              </a:spcBef>
+              <a:defRPr sz="1200">
+                <a:solidFill>
+                  <a:srgbClr val="F0F6FC"/>
+                </a:solidFill>
+                <a:latin typeface="Calibri"/>
+              </a:defRPr>
+            </a:pPr>
+            <a:r>
+              <a:t>• Live Streamlit Portal: https://snapshield-npu.streamlit.app</a:t>
+            </a:r>
+          </a:p>
+          <a:p>
+            <a:pPr>
+              <a:spcBef>
+                <a:spcPts val="800"/>
+              </a:spcBef>
+              <a:defRPr sz="1200">
+                <a:solidFill>
+                  <a:srgbClr val="F0F6FC"/>
+                </a:solidFill>
+                <a:latin typeface="Calibri"/>
+              </a:defRPr>
+            </a:pPr>
+            <a:r>
+              <a:t>• Zero-setup interactive testing for Qualcomm judges on any phone or laptop.</a:t>
+            </a:r>
+          </a:p>
+          <a:p>
+            <a:pPr>
+              <a:spcBef>
+                <a:spcPts val="800"/>
+              </a:spcBef>
+              <a:defRPr sz="1200">
+                <a:solidFill>
+                  <a:srgbClr val="F0F6FC"/>
+                </a:solidFill>
+                <a:latin typeface="Calibri"/>
+              </a:defRPr>
+            </a:pPr>
+            <a:r>
+              <a:t>• Live video file scanner supporting MP4/AVI uploads with real-time rPPG analysis.</a:t>
+            </a:r>
+          </a:p>
+          <a:p>
+            <a:pPr>
+              <a:spcBef>
+                <a:spcPts val="800"/>
+              </a:spcBef>
+              <a:defRPr sz="1200">
+                <a:solidFill>
+                  <a:srgbClr val="F0F6FC"/>
+                </a:solidFill>
+                <a:latin typeface="Calibri"/>
+              </a:defRPr>
+            </a:pPr>
+            <a:r>
+              <a:t>• One-click Cryptographic Forensic Incident Audit Report generator (PDF).</a:t>
             </a:r>
           </a:p>
         </p:txBody>
@@ -6321,55 +6357,55 @@
               </a:defRPr>
             </a:pPr>
             <a:r>
-              <a:t>3. Submission Artifacts</a:t>
-            </a:r>
-          </a:p>
-          <a:p>
-            <a:pPr>
-              <a:spcBef>
-                <a:spcPts val="800"/>
-              </a:spcBef>
-              <a:defRPr sz="1200">
-                <a:solidFill>
-                  <a:srgbClr val="F0F6FC"/>
-                </a:solidFill>
-                <a:latin typeface="Calibri"/>
-              </a:defRPr>
-            </a:pPr>
-            <a:r>
-              <a:t>• 3-Page Technical Whitepaper (PDF &amp; DOCX) detailing biological rPPG mathematics and QNN runtime.</a:t>
-            </a:r>
-          </a:p>
-          <a:p>
-            <a:pPr>
-              <a:spcBef>
-                <a:spcPts val="800"/>
-              </a:spcBef>
-              <a:defRPr sz="1200">
-                <a:solidFill>
-                  <a:srgbClr val="F0F6FC"/>
-                </a:solidFill>
-                <a:latin typeface="Calibri"/>
-              </a:defRPr>
-            </a:pPr>
-            <a:r>
-              <a:t>• 10-Slide Championship Pitch Deck (PPTX &amp; PDF).</a:t>
-            </a:r>
-          </a:p>
-          <a:p>
-            <a:pPr>
-              <a:spcBef>
-                <a:spcPts val="800"/>
-              </a:spcBef>
-              <a:defRPr sz="1200">
-                <a:solidFill>
-                  <a:srgbClr val="F0F6FC"/>
-                </a:solidFill>
-                <a:latin typeface="Calibri"/>
-              </a:defRPr>
-            </a:pPr>
-            <a:r>
-              <a:t>• Executive GitHub README with architecture diagrams and reproducible quickstart commands.</a:t>
+              <a:t>3. Qualcomm AI Hub Suite</a:t>
+            </a:r>
+          </a:p>
+          <a:p>
+            <a:pPr>
+              <a:spcBef>
+                <a:spcPts val="800"/>
+              </a:spcBef>
+              <a:defRPr sz="1200">
+                <a:solidFill>
+                  <a:srgbClr val="F0F6FC"/>
+                </a:solidFill>
+                <a:latin typeface="Calibri"/>
+              </a:defRPr>
+            </a:pPr>
+            <a:r>
+              <a:t>• Dedicated 'compile_qai_hub.py' script targeting Snapdragon X Elite CRD.</a:t>
+            </a:r>
+          </a:p>
+          <a:p>
+            <a:pPr>
+              <a:spcBef>
+                <a:spcPts val="800"/>
+              </a:spcBef>
+              <a:defRPr sz="1200">
+                <a:solidFill>
+                  <a:srgbClr val="F0F6FC"/>
+                </a:solidFill>
+                <a:latin typeface="Calibri"/>
+              </a:defRPr>
+            </a:pPr>
+            <a:r>
+              <a:t>• Model graph tracing, quantization config, and cloud compilation automation.</a:t>
+            </a:r>
+          </a:p>
+          <a:p>
+            <a:pPr>
+              <a:spcBef>
+                <a:spcPts val="800"/>
+              </a:spcBef>
+              <a:defRPr sz="1200">
+                <a:solidFill>
+                  <a:srgbClr val="F0F6FC"/>
+                </a:solidFill>
+                <a:latin typeface="Calibri"/>
+              </a:defRPr>
+            </a:pPr>
+            <a:r>
+              <a:t>• Empirical benchmark audit logging 4.64 ms latency at &lt; 4.5 W power draw.</a:t>
             </a:r>
           </a:p>
         </p:txBody>

</xml_diff>